<commit_message>
feat(math): upgrade LaTeX mathematical typography and clean ASCII conversions across dashboard, presentation deck, and documentation
</commit_message>
<xml_diff>
--- a/Project_Aegis_Merged_Deck.pptx
+++ b/Project_Aegis_Merged_Deck.pptx
@@ -4986,7 +4986,7 @@
               </a:defRPr>
             </a:pPr>
             <a:r>
-              <a:t>False Positive Rate:  0.0% (decay tau=4s)  (Zero false alarms)</a:t>
+              <a:t>False Positive Rate:  0.0% (decay τ = 4.0 s)  (Zero false alarms)</a:t>
             </a:r>
           </a:p>
           <a:p>
@@ -6059,7 +6059,7 @@
               </a:defRPr>
             </a:pPr>
             <a:r>
-              <a:t>G1: TPR &gt;= 95%</a:t>
+              <a:t>G1: TPR ≥ 95%</a:t>
             </a:r>
           </a:p>
           <a:p>
@@ -6072,7 +6072,7 @@
               </a:defRPr>
             </a:pPr>
             <a:r>
-              <a:t>FPR = 0.0% (Goal &lt;= 1%)</a:t>
+              <a:t>FPR = 0.0% (Goal ≤ 1%)</a:t>
             </a:r>
           </a:p>
         </p:txBody>
@@ -6273,7 +6273,7 @@
               </a:defRPr>
             </a:pPr>
             <a:r>
-              <a:t>G3: Files Lost &lt;= 5</a:t>
+              <a:t>G3: Files Lost ≤ 5</a:t>
             </a:r>
           </a:p>
           <a:p>
@@ -6594,7 +6594,7 @@
               </a:defRPr>
             </a:pPr>
             <a:r>
-              <a:t>G6: PMU F1 &gt;= 0.90</a:t>
+              <a:t>G6: PMU F1 ≥ 0.90</a:t>
             </a:r>
           </a:p>
           <a:p>
@@ -8422,7 +8422,7 @@
               </a:defRPr>
             </a:pPr>
             <a:r>
-              <a:t>Accumulates weighted evidence into R(t) with exponential half-life decay tau = 4.0s.</a:t>
+              <a:t>Accumulates weighted evidence into R(t) with exponential half-life decay τ = 4.0 s.</a:t>
             </a:r>
           </a:p>
           <a:p>
@@ -8449,7 +8449,7 @@
               </a:defRPr>
             </a:pPr>
             <a:r>
-              <a:t>Crossing Tier 3 (&gt;=80.0) invokes bpf_send_signal(9) to terminate the offending thread group instantly.</a:t>
+              <a:t>Crossing Tier 3 (≥ 80.0) invokes bpf_send_signal(9) to terminate the offending thread group instantly.</a:t>
             </a:r>
           </a:p>
           <a:p>
@@ -8993,8 +8993,8 @@
         </p:nvSpPr>
         <p:spPr>
           <a:xfrm>
-            <a:off x="960120" y="1920240"/>
-            <a:ext cx="4114800" cy="4069080"/>
+            <a:off x="960120" y="1874519"/>
+            <a:ext cx="4114800" cy="2011680"/>
           </a:xfrm>
           <a:prstGeom prst="rect">
             <a:avLst/>
@@ -9009,7 +9009,7 @@
           <a:p>
             <a:pPr>
               <a:spcAft>
-                <a:spcPts val="800"/>
+                <a:spcPts val="400"/>
               </a:spcAft>
               <a:defRPr sz="1000" b="1">
                 <a:solidFill>
@@ -9018,12 +9018,12 @@
               </a:defRPr>
             </a:pPr>
             <a:r>
-              <a:t>THE KERNEL MATH CHALLENGE &amp; SOLUTION</a:t>
-            </a:r>
-          </a:p>
-          <a:p>
-            <a:pPr>
-              <a:defRPr sz="1050" b="1">
+              <a:t>THE KERNEL MATH CHALLENGE &amp; DERIVATION</a:t>
+            </a:r>
+          </a:p>
+          <a:p>
+            <a:pPr>
+              <a:defRPr sz="1000" b="1">
                 <a:solidFill>
                   <a:srgbClr val="4ADE80"/>
                 </a:solidFill>
@@ -9036,9 +9036,9 @@
           <a:p>
             <a:pPr>
               <a:spcAft>
-                <a:spcPts val="500"/>
-              </a:spcAft>
-              <a:defRPr sz="900">
+                <a:spcPts val="200"/>
+              </a:spcAft>
+              <a:defRPr sz="850">
                 <a:solidFill>
                   <a:srgbClr val="94A3B8"/>
                 </a:solidFill>
@@ -9050,7 +9050,7 @@
           </a:p>
           <a:p>
             <a:pPr>
-              <a:defRPr sz="1050" b="1">
+              <a:defRPr sz="1000" b="1">
                 <a:solidFill>
                   <a:srgbClr val="4ADE80"/>
                 </a:solidFill>
@@ -9063,94 +9063,36 @@
           <a:p>
             <a:pPr>
               <a:spcAft>
-                <a:spcPts val="500"/>
-              </a:spcAft>
-              <a:defRPr sz="900">
+                <a:spcPts val="200"/>
+              </a:spcAft>
+              <a:defRPr sz="850">
                 <a:solidFill>
                   <a:srgbClr val="94A3B8"/>
                 </a:solidFill>
               </a:defRPr>
             </a:pPr>
             <a:r>
-              <a:t>Calculated entirely using integer bit-shifts (scaled by 2^16 = 65,536) and precomputed 4097-entry n·log2(n) lookup tables.</a:t>
-            </a:r>
-          </a:p>
-          <a:p>
-            <a:pPr>
-              <a:defRPr sz="1050" b="1">
+              <a:t>Calculated entirely using integer bit-shifts (scaled by 2¹⁶ = 65,536) and precomputed 4097-entry n·log2(n) lookup tables.</a:t>
+            </a:r>
+          </a:p>
+          <a:p>
+            <a:pPr>
+              <a:defRPr sz="1000" b="1">
                 <a:solidFill>
                   <a:srgbClr val="4ADE80"/>
                 </a:solidFill>
               </a:defRPr>
             </a:pPr>
             <a:r>
-              <a:t>Miller–Madow Bias Correction</a:t>
-            </a:r>
-          </a:p>
-          <a:p>
-            <a:pPr>
-              <a:spcAft>
-                <a:spcPts val="500"/>
-              </a:spcAft>
-              <a:defRPr sz="900">
-                <a:solidFill>
-                  <a:srgbClr val="94A3B8"/>
-                </a:solidFill>
-              </a:defRPr>
-            </a:pPr>
-            <a:r>
-              <a:t>Compensates for finite sample size (N &lt;= 4096) bias via asymptotic correction:</a:t>
-            </a:r>
-            <a:br/>
-            <a:r>
-              <a:t>H_MM = H_obs + (K_obs - 1) / (2·N·ln2)</a:t>
-            </a:r>
-          </a:p>
-          <a:p>
-            <a:pPr>
-              <a:defRPr sz="1050" b="1">
-                <a:solidFill>
-                  <a:srgbClr val="4ADE80"/>
-                </a:solidFill>
-              </a:defRPr>
-            </a:pPr>
-            <a:r>
-              <a:t>Empirical Precision</a:t>
-            </a:r>
-          </a:p>
-          <a:p>
-            <a:pPr>
-              <a:spcAft>
-                <a:spcPts val="500"/>
-              </a:spcAft>
-              <a:defRPr sz="900">
-                <a:solidFill>
-                  <a:srgbClr val="94A3B8"/>
-                </a:solidFill>
-              </a:defRPr>
-            </a:pPr>
-            <a:r>
-              <a:t>Maximum divergence against 64-bit IEEE double float is &lt; 0.00003 bits across 200 random vectors.</a:t>
-            </a:r>
-          </a:p>
-          <a:p>
-            <a:pPr>
-              <a:defRPr sz="1050" b="1">
-                <a:solidFill>
-                  <a:srgbClr val="4ADE80"/>
-                </a:solidFill>
-              </a:defRPr>
-            </a:pPr>
-            <a:r>
               <a:t>Strict 7.80 bits/byte Gate</a:t>
             </a:r>
           </a:p>
           <a:p>
             <a:pPr>
               <a:spcAft>
-                <a:spcPts val="500"/>
-              </a:spcAft>
-              <a:defRPr sz="900">
+                <a:spcPts val="200"/>
+              </a:spcAft>
+              <a:defRPr sz="850">
                 <a:solidFill>
                   <a:srgbClr val="94A3B8"/>
                 </a:solidFill>
@@ -9164,7 +9106,7 @@
       </p:sp>
       <p:pic>
         <p:nvPicPr>
-          <p:cNvPr id="8" name="Picture 7" descr="entropy_spectrum.png"/>
+          <p:cNvPr id="8" name="Picture 7" descr="formula_miller_madow.png"/>
           <p:cNvPicPr>
             <a:picLocks noChangeAspect="1"/>
           </p:cNvPicPr>
@@ -9178,6 +9120,65 @@
         </p:blipFill>
         <p:spPr>
           <a:xfrm>
+            <a:off x="960120" y="3977639"/>
+            <a:ext cx="4114800" cy="862781"/>
+          </a:xfrm>
+          <a:prstGeom prst="rect">
+            <a:avLst/>
+          </a:prstGeom>
+        </p:spPr>
+      </p:pic>
+      <p:sp>
+        <p:nvSpPr>
+          <p:cNvPr id="9" name="TextBox 8"/>
+          <p:cNvSpPr txBox="1"/>
+          <p:nvPr/>
+        </p:nvSpPr>
+        <p:spPr>
+          <a:xfrm>
+            <a:off x="960120" y="5303520"/>
+            <a:ext cx="4114800" cy="777240"/>
+          </a:xfrm>
+          <a:prstGeom prst="rect">
+            <a:avLst/>
+          </a:prstGeom>
+          <a:noFill/>
+        </p:spPr>
+        <p:txBody>
+          <a:bodyPr wrap="square">
+            <a:spAutoFit/>
+          </a:bodyPr>
+          <a:lstStyle/>
+          <a:p>
+            <a:pPr>
+              <a:defRPr sz="850">
+                <a:solidFill>
+                  <a:srgbClr val="CBD5E1"/>
+                </a:solidFill>
+              </a:defRPr>
+            </a:pPr>
+            <a:r>
+              <a:t>EMPIRICAL PRECISION: Maximum divergence against 64-bit IEEE double float is &lt; 0.00003 bits across 200 random vectors.</a:t>
+            </a:r>
+          </a:p>
+        </p:txBody>
+      </p:sp>
+      <p:pic>
+        <p:nvPicPr>
+          <p:cNvPr id="10" name="Picture 9" descr="entropy_spectrum.png"/>
+          <p:cNvPicPr>
+            <a:picLocks noChangeAspect="1"/>
+          </p:cNvPicPr>
+          <p:nvPr/>
+        </p:nvPicPr>
+        <p:blipFill>
+          <a:blip r:embed="rId3"/>
+          <a:stretch>
+            <a:fillRect/>
+          </a:stretch>
+        </p:blipFill>
+        <p:spPr>
+          <a:xfrm>
             <a:off x="5532120" y="1737360"/>
             <a:ext cx="5925312" cy="2798064"/>
           </a:xfrm>
@@ -9188,7 +9189,7 @@
       </p:pic>
       <p:sp>
         <p:nvSpPr>
-          <p:cNvPr id="9" name="Rounded Rectangle 8"/>
+          <p:cNvPr id="11" name="Rounded Rectangle 10"/>
           <p:cNvSpPr/>
           <p:nvPr/>
         </p:nvSpPr>
@@ -9233,7 +9234,7 @@
       </p:sp>
       <p:sp>
         <p:nvSpPr>
-          <p:cNvPr id="10" name="TextBox 9"/>
+          <p:cNvPr id="12" name="TextBox 11"/>
           <p:cNvSpPr txBox="1"/>
           <p:nvPr/>
         </p:nvSpPr>
@@ -10081,8 +10082,8 @@
         </p:nvSpPr>
         <p:spPr>
           <a:xfrm>
-            <a:off x="960120" y="1920240"/>
-            <a:ext cx="4297680" cy="4069080"/>
+            <a:off x="960120" y="1874519"/>
+            <a:ext cx="4297680" cy="2011680"/>
           </a:xfrm>
           <a:prstGeom prst="rect">
             <a:avLst/>
@@ -10097,7 +10098,7 @@
           <a:p>
             <a:pPr>
               <a:spcAft>
-                <a:spcPts val="800"/>
+                <a:spcPts val="400"/>
               </a:spcAft>
               <a:defRPr sz="1000" b="1">
                 <a:solidFill>
@@ -10111,7 +10112,7 @@
           </a:p>
           <a:p>
             <a:pPr>
-              <a:defRPr sz="1050" b="1">
+              <a:defRPr sz="1000" b="1">
                 <a:solidFill>
                   <a:srgbClr val="FFFFFF"/>
                 </a:solidFill>
@@ -10124,9 +10125,9 @@
           <a:p>
             <a:pPr>
               <a:spcAft>
-                <a:spcPts val="500"/>
-              </a:spcAft>
-              <a:defRPr sz="900">
+                <a:spcPts val="200"/>
+              </a:spcAft>
+              <a:defRPr sz="850">
                 <a:solidFill>
                   <a:srgbClr val="94A3B8"/>
                 </a:solidFill>
@@ -10138,125 +10139,63 @@
           </a:p>
           <a:p>
             <a:pPr>
-              <a:defRPr sz="1050" b="1">
+              <a:defRPr sz="1000" b="1">
                 <a:solidFill>
                   <a:srgbClr val="FFFFFF"/>
                 </a:solidFill>
               </a:defRPr>
             </a:pPr>
             <a:r>
-              <a:t>Fast Integer Bit-Shift Decay</a:t>
-            </a:r>
-          </a:p>
-          <a:p>
-            <a:pPr>
-              <a:spcAft>
-                <a:spcPts val="500"/>
-              </a:spcAft>
-              <a:defRPr sz="900">
+              <a:t>Inter-Write Pause Dissipation</a:t>
+            </a:r>
+          </a:p>
+          <a:p>
+            <a:pPr>
+              <a:spcAft>
+                <a:spcPts val="200"/>
+              </a:spcAft>
+              <a:defRPr sz="850">
                 <a:solidFill>
                   <a:srgbClr val="94A3B8"/>
                 </a:solidFill>
               </a:defRPr>
             </a:pPr>
             <a:r>
-              <a:t>Aegis implements exponential risk decay via bit-shifts in Q8.8 math:</a:t>
-            </a:r>
-            <a:br/>
-            <a:r>
-              <a:t>R(t) = R_0 &gt;&gt; (elapsed_ms / 4000ms)</a:t>
-            </a:r>
-            <a:br/>
-            <a:r>
-              <a:t>No floating-point exponentiation required.</a:t>
-            </a:r>
-          </a:p>
-          <a:p>
-            <a:pPr>
-              <a:defRPr sz="1050" b="1">
+              <a:t>Legitimate compression engines pause between I/O blocks for calculations. Pauses allow risk scores to decay safely to baseline.</a:t>
+            </a:r>
+          </a:p>
+          <a:p>
+            <a:pPr>
+              <a:defRPr sz="1000" b="1">
                 <a:solidFill>
                   <a:srgbClr val="FFFFFF"/>
                 </a:solidFill>
               </a:defRPr>
             </a:pPr>
             <a:r>
-              <a:t>Inter-Write Pause Dissipation</a:t>
-            </a:r>
-          </a:p>
-          <a:p>
-            <a:pPr>
-              <a:spcAft>
-                <a:spcPts val="500"/>
-              </a:spcAft>
-              <a:defRPr sz="900">
+              <a:t>Adaptive 3-Tier Sampling Gate</a:t>
+            </a:r>
+          </a:p>
+          <a:p>
+            <a:pPr>
+              <a:spcAft>
+                <a:spcPts val="200"/>
+              </a:spcAft>
+              <a:defRPr sz="850">
                 <a:solidFill>
                   <a:srgbClr val="94A3B8"/>
                 </a:solidFill>
               </a:defRPr>
             </a:pPr>
             <a:r>
-              <a:t>Legitimate compression engines pause between I/O blocks for compression calculations. Pauses allow risk scores to decay safely to baseline.</a:t>
-            </a:r>
-          </a:p>
-          <a:p>
-            <a:pPr>
-              <a:defRPr sz="1050" b="1">
-                <a:solidFill>
-                  <a:srgbClr val="FFFFFF"/>
-                </a:solidFill>
-              </a:defRPr>
-            </a:pPr>
-            <a:r>
-              <a:t>Adaptive 3-Tier Sampling Gate</a:t>
-            </a:r>
-          </a:p>
-          <a:p>
-            <a:pPr>
-              <a:spcAft>
-                <a:spcPts val="500"/>
-              </a:spcAft>
-              <a:defRPr sz="900">
-                <a:solidFill>
-                  <a:srgbClr val="94A3B8"/>
-                </a:solidFill>
-              </a:defRPr>
-            </a:pPr>
-            <a:r>
               <a:t>Tier 0 inspects 1-in-16 writes (0.78% CPU). If risk rises, inspection accelerates to 1-in-4 (Tier 1) and 100% continuous inspection (Tier 2).</a:t>
-            </a:r>
-          </a:p>
-          <a:p>
-            <a:pPr>
-              <a:defRPr sz="1050" b="1">
-                <a:solidFill>
-                  <a:srgbClr val="FFFFFF"/>
-                </a:solidFill>
-              </a:defRPr>
-            </a:pPr>
-            <a:r>
-              <a:t>0.0% Empirical False Positive Rate</a:t>
-            </a:r>
-          </a:p>
-          <a:p>
-            <a:pPr>
-              <a:spcAft>
-                <a:spcPts val="500"/>
-              </a:spcAft>
-              <a:defRPr sz="900">
-                <a:solidFill>
-                  <a:srgbClr val="94A3B8"/>
-                </a:solidFill>
-              </a:defRPr>
-            </a:pPr>
-            <a:r>
-              <a:t>Rigorously evaluated across 2,000 mixed archives, binaries, and compressed media with zero false kills.</a:t>
             </a:r>
           </a:p>
         </p:txBody>
       </p:sp>
       <p:pic>
         <p:nvPicPr>
-          <p:cNvPr id="8" name="Picture 7" descr="risk_decay_timeline.png"/>
+          <p:cNvPr id="8" name="Picture 7" descr="formula_risk_decay.png"/>
           <p:cNvPicPr>
             <a:picLocks noChangeAspect="1"/>
           </p:cNvPicPr>
@@ -10270,6 +10209,65 @@
         </p:blipFill>
         <p:spPr>
           <a:xfrm>
+            <a:off x="960120" y="4069080"/>
+            <a:ext cx="4297680" cy="901126"/>
+          </a:xfrm>
+          <a:prstGeom prst="rect">
+            <a:avLst/>
+          </a:prstGeom>
+        </p:spPr>
+      </p:pic>
+      <p:sp>
+        <p:nvSpPr>
+          <p:cNvPr id="9" name="TextBox 8"/>
+          <p:cNvSpPr txBox="1"/>
+          <p:nvPr/>
+        </p:nvSpPr>
+        <p:spPr>
+          <a:xfrm>
+            <a:off x="960120" y="5349240"/>
+            <a:ext cx="4297680" cy="731520"/>
+          </a:xfrm>
+          <a:prstGeom prst="rect">
+            <a:avLst/>
+          </a:prstGeom>
+          <a:noFill/>
+        </p:spPr>
+        <p:txBody>
+          <a:bodyPr wrap="square">
+            <a:spAutoFit/>
+          </a:bodyPr>
+          <a:lstStyle/>
+          <a:p>
+            <a:pPr>
+              <a:defRPr sz="850">
+                <a:solidFill>
+                  <a:srgbClr val="4ADE80"/>
+                </a:solidFill>
+              </a:defRPr>
+            </a:pPr>
+            <a:r>
+              <a:t>EMPIRICAL VERIFICATION: 0.0% False Positive Rate across 2,000 mixed archives, binaries, and media.</a:t>
+            </a:r>
+          </a:p>
+        </p:txBody>
+      </p:sp>
+      <p:pic>
+        <p:nvPicPr>
+          <p:cNvPr id="10" name="Picture 9" descr="risk_decay_timeline.png"/>
+          <p:cNvPicPr>
+            <a:picLocks noChangeAspect="1"/>
+          </p:cNvPicPr>
+          <p:nvPr/>
+        </p:nvPicPr>
+        <p:blipFill>
+          <a:blip r:embed="rId3"/>
+          <a:stretch>
+            <a:fillRect/>
+          </a:stretch>
+        </p:blipFill>
+        <p:spPr>
+          <a:xfrm>
             <a:off x="5760720" y="1737360"/>
             <a:ext cx="5699455" cy="2933543"/>
           </a:xfrm>
@@ -10280,7 +10278,7 @@
       </p:pic>
       <p:sp>
         <p:nvSpPr>
-          <p:cNvPr id="9" name="Rounded Rectangle 8"/>
+          <p:cNvPr id="11" name="Rounded Rectangle 10"/>
           <p:cNvSpPr/>
           <p:nvPr/>
         </p:nvSpPr>
@@ -10325,7 +10323,7 @@
       </p:sp>
       <p:sp>
         <p:nvSpPr>
-          <p:cNvPr id="10" name="TextBox 9"/>
+          <p:cNvPr id="12" name="TextBox 11"/>
           <p:cNvSpPr txBox="1"/>
           <p:nvPr/>
         </p:nvSpPr>
@@ -10818,7 +10816,7 @@
               </a:defRPr>
             </a:pPr>
             <a:r>
-              <a:t>Sample entropy &gt;= 7.80 bits/byte gated by filters</a:t>
+              <a:t>Sample entropy ≥ 7.80 bits/byte gated by filters</a:t>
             </a:r>
           </a:p>
         </p:txBody>
@@ -10913,7 +10911,7 @@
               </a:defRPr>
             </a:pPr>
             <a:r>
-              <a:t>Tier 3 — Quarantine (R &gt;= 80.0)</a:t>
+              <a:t>Tier 3 — Quarantine (R(t) ≥ 80.0)</a:t>
             </a:r>
           </a:p>
           <a:p>
@@ -10940,7 +10938,7 @@
               </a:defRPr>
             </a:pPr>
             <a:r>
-              <a:t>Tier 2 — Hostile (R &gt;= 50.0)</a:t>
+              <a:t>Tier 2 — Hostile (R(t) ≥ 50.0)</a:t>
             </a:r>
           </a:p>
           <a:p>
@@ -10967,7 +10965,7 @@
               </a:defRPr>
             </a:pPr>
             <a:r>
-              <a:t>Tier 1 — Suspicious (R &gt;= 25.0)</a:t>
+              <a:t>Tier 1 — Suspicious (R(t) ≥ 25.0)</a:t>
             </a:r>
           </a:p>
           <a:p>

</xml_diff>